<commit_message>
Fix PowerPoint open error: enforce min 1-EMU line dimensions (zero-height logo lines corrupted files); regenerate all decks
</commit_message>
<xml_diff>
--- a/LIKA_Source_Code.pptx
+++ b/LIKA_Source_Code.pptx
@@ -1375,7 +1375,7 @@
         <p:spPr>
           <a:xfrm flipH="0" flipV="0">
             <a:off x="1530000" y="3330000"/>
-            <a:ext cx="482800" cy="0"/>
+            <a:ext cx="482800" cy="1"/>
           </a:xfrm>
           <a:prstGeom prst="line">
             <a:avLst/>
@@ -1453,7 +1453,7 @@
         <p:spPr>
           <a:xfrm flipH="1" flipV="0">
             <a:off x="1047200" y="3330000"/>
-            <a:ext cx="482800" cy="0"/>
+            <a:ext cx="482800" cy="1"/>
           </a:xfrm>
           <a:prstGeom prst="line">
             <a:avLst/>

</xml_diff>